<commit_message>
Add guard-rails slide (slide 2) to director deck
Slide 2 "Guard Rails — Built-In AI Safety": the 7 layers with LIVE vs
DESIGNED status, verified proof (25/25 attacks blocked, Raj 96/100,
4-of-7 live), and a why-it-matters callout. Matches slide 1's palette.

Co-Authored-By: Claude Opus 4.8 (1M context) <noreply@anthropic.com>
</commit_message>
<xml_diff>
--- a/demo-assets/director-slide.pptx
+++ b/demo-assets/director-slide.pptx
@@ -6,9 +6,10 @@
   </p:sldMasterIdLst>
   <p:sldIdLst>
     <p:sldId id="256" r:id="rId2"/>
+    <p:sldId id="257" r:id="rId3"/>
   </p:sldIdLst>
   <p:notesMasterIdLst>
-    <p:notesMasterId r:id="rId3"/>
+    <p:notesMasterId r:id="rId4"/>
   </p:notesMasterIdLst>
   <p:sldSz cx="12192000" cy="6858000"/>
   <p:notesSz cx="6858000" cy="12192000"/>
@@ -526,6 +527,94 @@
             <a:fld id="{F7021451-1387-4CA6-816F-3879F97B5CBC}" type="slidenum">
               <a:rPr lang="en-US"/>
               <a:t>1</a:t>
+            </a:fld>
+            <a:endParaRPr lang="en-US"/>
+          </a:p>
+        </p:txBody>
+      </p:sp>
+    </p:spTree>
+    <p:extLst>
+      <p:ext uri="{BB962C8B-B14F-4D97-AF65-F5344CB8AC3E}">
+        <p14:creationId xmlns:p14="http://schemas.microsoft.com/office/powerpoint/2010/main" val="1024086991"/>
+      </p:ext>
+    </p:extLst>
+  </p:cSld>
+  <p:clrMapOvr>
+    <a:masterClrMapping/>
+  </p:clrMapOvr>
+</p:notes>
+</file>
+
+<file path=ppt/notesSlides/notesSlide2.xml><?xml version="1.0" encoding="utf-8"?>
+<p:notes xmlns:a="http://schemas.openxmlformats.org/drawingml/2006/main" xmlns:r="http://schemas.openxmlformats.org/officeDocument/2006/relationships" xmlns:p="http://schemas.openxmlformats.org/presentationml/2006/main">
+  <p:cSld>
+    <p:spTree>
+      <p:nvGrpSpPr>
+        <p:cNvPr id="1" name=""/>
+        <p:cNvGrpSpPr/>
+        <p:nvPr/>
+      </p:nvGrpSpPr>
+      <p:grpSpPr>
+        <a:xfrm>
+          <a:off x="0" y="0"/>
+          <a:ext cx="0" cy="0"/>
+          <a:chOff x="0" y="0"/>
+          <a:chExt cx="0" cy="0"/>
+        </a:xfrm>
+      </p:grpSpPr>
+      <p:sp>
+        <p:nvSpPr>
+          <p:cNvPr id="2" name="Slide Image Placeholder 1"/>
+          <p:cNvSpPr>
+            <a:spLocks noGrp="1" noRot="1" noChangeAspect="1"/>
+          </p:cNvSpPr>
+          <p:nvPr>
+            <p:ph type="sldImg"/>
+          </p:nvPr>
+        </p:nvSpPr>
+        <p:spPr/>
+      </p:sp>
+      <p:sp>
+        <p:nvSpPr>
+          <p:cNvPr id="3" name="Notes Placeholder 2"/>
+          <p:cNvSpPr>
+            <a:spLocks noGrp="1"/>
+          </p:cNvSpPr>
+          <p:nvPr>
+            <p:ph type="body" idx="1"/>
+          </p:nvPr>
+        </p:nvSpPr>
+        <p:spPr/>
+        <p:txBody>
+          <a:bodyPr/>
+          <a:lstStyle/>
+          <a:p>
+            <a:r>
+              <a:rPr lang="en-US" dirty="0"/>
+              <a:t/>
+            </a:r>
+            <a:endParaRPr lang="en-US" dirty="0"/>
+          </a:p>
+        </p:txBody>
+      </p:sp>
+      <p:sp>
+        <p:nvSpPr>
+          <p:cNvPr id="4" name="Slide Number Placeholder 3"/>
+          <p:cNvSpPr>
+            <a:spLocks noGrp="1"/>
+          </p:cNvSpPr>
+          <p:nvPr>
+            <p:ph type="sldNum" sz="quarter" idx="10"/>
+          </p:nvPr>
+        </p:nvSpPr>
+        <p:spPr/>
+        <p:txBody>
+          <a:bodyPr/>
+          <a:lstStyle/>
+          <a:p>
+            <a:fld id="{F7021451-1387-4CA6-816F-3879F97B5CBC}" type="slidenum">
+              <a:rPr lang="en-US"/>
+              <a:t>2</a:t>
             </a:fld>
             <a:endParaRPr lang="en-US"/>
           </a:p>
@@ -3197,6 +3286,1676 @@
 </p:sld>
 </file>
 
+<file path=ppt/slides/slide2.xml><?xml version="1.0" encoding="utf-8"?>
+<p:sld xmlns:a="http://schemas.openxmlformats.org/drawingml/2006/main" xmlns:r="http://schemas.openxmlformats.org/officeDocument/2006/relationships" xmlns:p="http://schemas.openxmlformats.org/presentationml/2006/main">
+  <p:cSld name="Slide 2">
+    <p:bg>
+      <p:bgPr>
+        <a:solidFill>
+          <a:srgbClr val="FFFFFF"/>
+        </a:solidFill>
+      </p:bgPr>
+    </p:bg>
+    <p:spTree>
+      <p:nvGrpSpPr>
+        <p:cNvPr id="1" name=""/>
+        <p:cNvGrpSpPr/>
+        <p:nvPr/>
+      </p:nvGrpSpPr>
+      <p:grpSpPr>
+        <a:xfrm>
+          <a:off x="0" y="0"/>
+          <a:ext cx="0" cy="0"/>
+          <a:chOff x="0" y="0"/>
+          <a:chExt cx="0" cy="0"/>
+        </a:xfrm>
+      </p:grpSpPr>
+      <p:sp>
+        <p:nvSpPr>
+          <p:cNvPr id="2" name="Text 0"/>
+          <p:cNvSpPr/>
+          <p:nvPr/>
+        </p:nvSpPr>
+        <p:spPr>
+          <a:xfrm>
+            <a:off x="457200" y="320040"/>
+            <a:ext cx="10058400" cy="640080"/>
+          </a:xfrm>
+          <a:prstGeom prst="rect">
+            <a:avLst/>
+          </a:prstGeom>
+          <a:noFill/>
+          <a:ln/>
+        </p:spPr>
+        <p:txBody>
+          <a:bodyPr wrap="square" lIns="0" tIns="0" rIns="0" bIns="0" rtlCol="0" anchor="ctr"/>
+          <a:lstStyle/>
+          <a:p>
+            <a:pPr indent="0" marL="0">
+              <a:buNone/>
+            </a:pPr>
+            <a:r>
+              <a:rPr lang="en-US" sz="3600" b="1" dirty="0">
+                <a:solidFill>
+                  <a:srgbClr val="1E2761"/>
+                </a:solidFill>
+                <a:latin typeface="Georgia" pitchFamily="34" charset="0"/>
+                <a:ea typeface="Georgia" pitchFamily="34" charset="-122"/>
+                <a:cs typeface="Georgia" pitchFamily="34" charset="-120"/>
+              </a:rPr>
+              <a:t>Guard Rails — Built-In AI Safety</a:t>
+            </a:r>
+            <a:endParaRPr lang="en-US" sz="3600" dirty="0"/>
+          </a:p>
+        </p:txBody>
+      </p:sp>
+      <p:sp>
+        <p:nvSpPr>
+          <p:cNvPr id="3" name="Text 1"/>
+          <p:cNvSpPr/>
+          <p:nvPr/>
+        </p:nvSpPr>
+        <p:spPr>
+          <a:xfrm>
+            <a:off x="457200" y="960120"/>
+            <a:ext cx="10058400" cy="365760"/>
+          </a:xfrm>
+          <a:prstGeom prst="rect">
+            <a:avLst/>
+          </a:prstGeom>
+          <a:noFill/>
+          <a:ln/>
+        </p:spPr>
+        <p:txBody>
+          <a:bodyPr wrap="square" lIns="0" tIns="0" rIns="0" bIns="0" rtlCol="0" anchor="ctr"/>
+          <a:lstStyle/>
+          <a:p>
+            <a:pPr indent="0" marL="0">
+              <a:buNone/>
+            </a:pPr>
+            <a:r>
+              <a:rPr lang="en-US" sz="1800" i="1" dirty="0">
+                <a:solidFill>
+                  <a:srgbClr val="555555"/>
+                </a:solidFill>
+                <a:latin typeface="Calibri" pitchFamily="34" charset="0"/>
+                <a:ea typeface="Calibri" pitchFamily="34" charset="-122"/>
+                <a:cs typeface="Calibri" pitchFamily="34" charset="-120"/>
+              </a:rPr>
+              <a:t>Attacks blocked before they cost a token.</a:t>
+            </a:r>
+            <a:endParaRPr lang="en-US" sz="1800" dirty="0"/>
+          </a:p>
+        </p:txBody>
+      </p:sp>
+      <p:sp>
+        <p:nvSpPr>
+          <p:cNvPr id="4" name="Text 2"/>
+          <p:cNvSpPr/>
+          <p:nvPr/>
+        </p:nvSpPr>
+        <p:spPr>
+          <a:xfrm>
+            <a:off x="457200" y="1554480"/>
+            <a:ext cx="3657600" cy="274320"/>
+          </a:xfrm>
+          <a:prstGeom prst="rect">
+            <a:avLst/>
+          </a:prstGeom>
+          <a:noFill/>
+          <a:ln/>
+        </p:spPr>
+        <p:txBody>
+          <a:bodyPr wrap="square" rtlCol="0" anchor="ctr"/>
+          <a:lstStyle/>
+          <a:p>
+            <a:pPr indent="0" marL="0">
+              <a:buNone/>
+            </a:pPr>
+            <a:r>
+              <a:rPr lang="en-US" sz="1200" b="1" spc="200" kern="0" dirty="0">
+                <a:solidFill>
+                  <a:srgbClr val="F96167"/>
+                </a:solidFill>
+                <a:latin typeface="Calibri" pitchFamily="34" charset="0"/>
+                <a:ea typeface="Calibri" pitchFamily="34" charset="-122"/>
+                <a:cs typeface="Calibri" pitchFamily="34" charset="-120"/>
+              </a:rPr>
+              <a:t>THE 7 LAYERS</a:t>
+            </a:r>
+            <a:endParaRPr lang="en-US" sz="1200" dirty="0"/>
+          </a:p>
+        </p:txBody>
+      </p:sp>
+      <p:sp>
+        <p:nvSpPr>
+          <p:cNvPr id="5" name="Shape 3"/>
+          <p:cNvSpPr/>
+          <p:nvPr/>
+        </p:nvSpPr>
+        <p:spPr>
+          <a:xfrm>
+            <a:off x="457200" y="1920240"/>
+            <a:ext cx="548640" cy="457200"/>
+          </a:xfrm>
+          <a:prstGeom prst="roundRect">
+            <a:avLst>
+              <a:gd name="adj" fmla="val 12000"/>
+            </a:avLst>
+          </a:prstGeom>
+          <a:solidFill>
+            <a:srgbClr val="1E2761"/>
+          </a:solidFill>
+          <a:ln w="12700">
+            <a:solidFill>
+              <a:srgbClr val="1E2761"/>
+            </a:solidFill>
+            <a:prstDash val="solid"/>
+          </a:ln>
+        </p:spPr>
+      </p:sp>
+      <p:sp>
+        <p:nvSpPr>
+          <p:cNvPr id="6" name="Text 4"/>
+          <p:cNvSpPr/>
+          <p:nvPr/>
+        </p:nvSpPr>
+        <p:spPr>
+          <a:xfrm>
+            <a:off x="457200" y="1920240"/>
+            <a:ext cx="548640" cy="457200"/>
+          </a:xfrm>
+          <a:prstGeom prst="rect">
+            <a:avLst/>
+          </a:prstGeom>
+          <a:noFill/>
+          <a:ln/>
+        </p:spPr>
+        <p:txBody>
+          <a:bodyPr wrap="square" lIns="0" tIns="0" rIns="0" bIns="0" rtlCol="0" anchor="ctr"/>
+          <a:lstStyle/>
+          <a:p>
+            <a:pPr algn="ctr" indent="0" marL="0">
+              <a:buNone/>
+            </a:pPr>
+            <a:r>
+              <a:rPr lang="en-US" sz="1400" b="1" dirty="0">
+                <a:solidFill>
+                  <a:srgbClr val="FFFFFF"/>
+                </a:solidFill>
+                <a:latin typeface="Calibri" pitchFamily="34" charset="0"/>
+                <a:ea typeface="Calibri" pitchFamily="34" charset="-122"/>
+                <a:cs typeface="Calibri" pitchFamily="34" charset="-120"/>
+              </a:rPr>
+              <a:t>L1</a:t>
+            </a:r>
+            <a:endParaRPr lang="en-US" sz="1400" dirty="0"/>
+          </a:p>
+        </p:txBody>
+      </p:sp>
+      <p:sp>
+        <p:nvSpPr>
+          <p:cNvPr id="7" name="Text 5"/>
+          <p:cNvSpPr/>
+          <p:nvPr/>
+        </p:nvSpPr>
+        <p:spPr>
+          <a:xfrm>
+            <a:off x="1143000" y="1920240"/>
+            <a:ext cx="4937760" cy="457200"/>
+          </a:xfrm>
+          <a:prstGeom prst="rect">
+            <a:avLst/>
+          </a:prstGeom>
+          <a:noFill/>
+          <a:ln/>
+        </p:spPr>
+        <p:txBody>
+          <a:bodyPr wrap="square" lIns="0" tIns="0" rIns="0" bIns="0" rtlCol="0" anchor="ctr"/>
+          <a:lstStyle/>
+          <a:p>
+            <a:pPr indent="0" marL="0">
+              <a:buNone/>
+            </a:pPr>
+            <a:r>
+              <a:rPr lang="en-US" sz="1300" b="1" dirty="0">
+                <a:solidFill>
+                  <a:srgbClr val="1E2761"/>
+                </a:solidFill>
+                <a:latin typeface="Calibri" pitchFamily="34" charset="0"/>
+                <a:ea typeface="Calibri" pitchFamily="34" charset="-122"/>
+                <a:cs typeface="Calibri" pitchFamily="34" charset="-120"/>
+              </a:rPr>
+              <a:t>Input sanitizer  </a:t>
+            </a:r>
+            <a:pPr indent="0" marL="0">
+              <a:buNone/>
+            </a:pPr>
+            <a:r>
+              <a:rPr lang="en-US" sz="1100" dirty="0">
+                <a:solidFill>
+                  <a:srgbClr val="555555"/>
+                </a:solidFill>
+                <a:latin typeface="Calibri" pitchFamily="34" charset="0"/>
+                <a:ea typeface="Calibri" pitchFamily="34" charset="-122"/>
+                <a:cs typeface="Calibri" pitchFamily="34" charset="-120"/>
+              </a:rPr>
+              <a:t>strips hidden characters, fake tags, oversized payloads — no AI, $0</a:t>
+            </a:r>
+            <a:endParaRPr lang="en-US" sz="1300" dirty="0"/>
+          </a:p>
+        </p:txBody>
+      </p:sp>
+      <p:sp>
+        <p:nvSpPr>
+          <p:cNvPr id="8" name="Text 6"/>
+          <p:cNvSpPr/>
+          <p:nvPr/>
+        </p:nvSpPr>
+        <p:spPr>
+          <a:xfrm>
+            <a:off x="6126480" y="1920240"/>
+            <a:ext cx="914400" cy="457200"/>
+          </a:xfrm>
+          <a:prstGeom prst="rect">
+            <a:avLst/>
+          </a:prstGeom>
+          <a:noFill/>
+          <a:ln/>
+        </p:spPr>
+        <p:txBody>
+          <a:bodyPr wrap="square" lIns="0" tIns="0" rIns="0" bIns="0" rtlCol="0" anchor="ctr"/>
+          <a:lstStyle/>
+          <a:p>
+            <a:pPr algn="ctr" indent="0" marL="0">
+              <a:buNone/>
+            </a:pPr>
+            <a:r>
+              <a:rPr lang="en-US" sz="1000" b="1" dirty="0">
+                <a:solidFill>
+                  <a:srgbClr val="2E7D32"/>
+                </a:solidFill>
+                <a:latin typeface="Calibri" pitchFamily="34" charset="0"/>
+                <a:ea typeface="Calibri" pitchFamily="34" charset="-122"/>
+                <a:cs typeface="Calibri" pitchFamily="34" charset="-120"/>
+              </a:rPr>
+              <a:t>LIVE</a:t>
+            </a:r>
+            <a:endParaRPr lang="en-US" sz="1000" dirty="0"/>
+          </a:p>
+        </p:txBody>
+      </p:sp>
+      <p:sp>
+        <p:nvSpPr>
+          <p:cNvPr id="9" name="Shape 7"/>
+          <p:cNvSpPr/>
+          <p:nvPr/>
+        </p:nvSpPr>
+        <p:spPr>
+          <a:xfrm>
+            <a:off x="457200" y="2487168"/>
+            <a:ext cx="548640" cy="457200"/>
+          </a:xfrm>
+          <a:prstGeom prst="roundRect">
+            <a:avLst>
+              <a:gd name="adj" fmla="val 12000"/>
+            </a:avLst>
+          </a:prstGeom>
+          <a:solidFill>
+            <a:srgbClr val="1E2761"/>
+          </a:solidFill>
+          <a:ln w="12700">
+            <a:solidFill>
+              <a:srgbClr val="1E2761"/>
+            </a:solidFill>
+            <a:prstDash val="solid"/>
+          </a:ln>
+        </p:spPr>
+      </p:sp>
+      <p:sp>
+        <p:nvSpPr>
+          <p:cNvPr id="10" name="Text 8"/>
+          <p:cNvSpPr/>
+          <p:nvPr/>
+        </p:nvSpPr>
+        <p:spPr>
+          <a:xfrm>
+            <a:off x="457200" y="2487168"/>
+            <a:ext cx="548640" cy="457200"/>
+          </a:xfrm>
+          <a:prstGeom prst="rect">
+            <a:avLst/>
+          </a:prstGeom>
+          <a:noFill/>
+          <a:ln/>
+        </p:spPr>
+        <p:txBody>
+          <a:bodyPr wrap="square" lIns="0" tIns="0" rIns="0" bIns="0" rtlCol="0" anchor="ctr"/>
+          <a:lstStyle/>
+          <a:p>
+            <a:pPr algn="ctr" indent="0" marL="0">
+              <a:buNone/>
+            </a:pPr>
+            <a:r>
+              <a:rPr lang="en-US" sz="1400" b="1" dirty="0">
+                <a:solidFill>
+                  <a:srgbClr val="FFFFFF"/>
+                </a:solidFill>
+                <a:latin typeface="Calibri" pitchFamily="34" charset="0"/>
+                <a:ea typeface="Calibri" pitchFamily="34" charset="-122"/>
+                <a:cs typeface="Calibri" pitchFamily="34" charset="-120"/>
+              </a:rPr>
+              <a:t>L2</a:t>
+            </a:r>
+            <a:endParaRPr lang="en-US" sz="1400" dirty="0"/>
+          </a:p>
+        </p:txBody>
+      </p:sp>
+      <p:sp>
+        <p:nvSpPr>
+          <p:cNvPr id="11" name="Text 9"/>
+          <p:cNvSpPr/>
+          <p:nvPr/>
+        </p:nvSpPr>
+        <p:spPr>
+          <a:xfrm>
+            <a:off x="1143000" y="2487168"/>
+            <a:ext cx="4937760" cy="457200"/>
+          </a:xfrm>
+          <a:prstGeom prst="rect">
+            <a:avLst/>
+          </a:prstGeom>
+          <a:noFill/>
+          <a:ln/>
+        </p:spPr>
+        <p:txBody>
+          <a:bodyPr wrap="square" lIns="0" tIns="0" rIns="0" bIns="0" rtlCol="0" anchor="ctr"/>
+          <a:lstStyle/>
+          <a:p>
+            <a:pPr indent="0" marL="0">
+              <a:buNone/>
+            </a:pPr>
+            <a:r>
+              <a:rPr lang="en-US" sz="1300" b="1" dirty="0">
+                <a:solidFill>
+                  <a:srgbClr val="1E2761"/>
+                </a:solidFill>
+                <a:latin typeface="Calibri" pitchFamily="34" charset="0"/>
+                <a:ea typeface="Calibri" pitchFamily="34" charset="-122"/>
+                <a:cs typeface="Calibri" pitchFamily="34" charset="-120"/>
+              </a:rPr>
+              <a:t>Injection classifier  </a:t>
+            </a:r>
+            <a:pPr indent="0" marL="0">
+              <a:buNone/>
+            </a:pPr>
+            <a:r>
+              <a:rPr lang="en-US" sz="1100" dirty="0">
+                <a:solidFill>
+                  <a:srgbClr val="555555"/>
+                </a:solidFill>
+                <a:latin typeface="Calibri" pitchFamily="34" charset="0"/>
+                <a:ea typeface="Calibri" pitchFamily="34" charset="-122"/>
+                <a:cs typeface="Calibri" pitchFamily="34" charset="-120"/>
+              </a:rPr>
+              <a:t>Haiku scores every input; blocks attacks — pennies per check</a:t>
+            </a:r>
+            <a:endParaRPr lang="en-US" sz="1300" dirty="0"/>
+          </a:p>
+        </p:txBody>
+      </p:sp>
+      <p:sp>
+        <p:nvSpPr>
+          <p:cNvPr id="12" name="Text 10"/>
+          <p:cNvSpPr/>
+          <p:nvPr/>
+        </p:nvSpPr>
+        <p:spPr>
+          <a:xfrm>
+            <a:off x="6126480" y="2487168"/>
+            <a:ext cx="914400" cy="457200"/>
+          </a:xfrm>
+          <a:prstGeom prst="rect">
+            <a:avLst/>
+          </a:prstGeom>
+          <a:noFill/>
+          <a:ln/>
+        </p:spPr>
+        <p:txBody>
+          <a:bodyPr wrap="square" lIns="0" tIns="0" rIns="0" bIns="0" rtlCol="0" anchor="ctr"/>
+          <a:lstStyle/>
+          <a:p>
+            <a:pPr algn="ctr" indent="0" marL="0">
+              <a:buNone/>
+            </a:pPr>
+            <a:r>
+              <a:rPr lang="en-US" sz="1000" b="1" dirty="0">
+                <a:solidFill>
+                  <a:srgbClr val="2E7D32"/>
+                </a:solidFill>
+                <a:latin typeface="Calibri" pitchFamily="34" charset="0"/>
+                <a:ea typeface="Calibri" pitchFamily="34" charset="-122"/>
+                <a:cs typeface="Calibri" pitchFamily="34" charset="-120"/>
+              </a:rPr>
+              <a:t>LIVE</a:t>
+            </a:r>
+            <a:endParaRPr lang="en-US" sz="1000" dirty="0"/>
+          </a:p>
+        </p:txBody>
+      </p:sp>
+      <p:sp>
+        <p:nvSpPr>
+          <p:cNvPr id="13" name="Shape 11"/>
+          <p:cNvSpPr/>
+          <p:nvPr/>
+        </p:nvSpPr>
+        <p:spPr>
+          <a:xfrm>
+            <a:off x="457200" y="3054096"/>
+            <a:ext cx="548640" cy="457200"/>
+          </a:xfrm>
+          <a:prstGeom prst="roundRect">
+            <a:avLst>
+              <a:gd name="adj" fmla="val 12000"/>
+            </a:avLst>
+          </a:prstGeom>
+          <a:solidFill>
+            <a:srgbClr val="1E2761"/>
+          </a:solidFill>
+          <a:ln w="12700">
+            <a:solidFill>
+              <a:srgbClr val="1E2761"/>
+            </a:solidFill>
+            <a:prstDash val="solid"/>
+          </a:ln>
+        </p:spPr>
+      </p:sp>
+      <p:sp>
+        <p:nvSpPr>
+          <p:cNvPr id="14" name="Text 12"/>
+          <p:cNvSpPr/>
+          <p:nvPr/>
+        </p:nvSpPr>
+        <p:spPr>
+          <a:xfrm>
+            <a:off x="457200" y="3054096"/>
+            <a:ext cx="548640" cy="457200"/>
+          </a:xfrm>
+          <a:prstGeom prst="rect">
+            <a:avLst/>
+          </a:prstGeom>
+          <a:noFill/>
+          <a:ln/>
+        </p:spPr>
+        <p:txBody>
+          <a:bodyPr wrap="square" lIns="0" tIns="0" rIns="0" bIns="0" rtlCol="0" anchor="ctr"/>
+          <a:lstStyle/>
+          <a:p>
+            <a:pPr algn="ctr" indent="0" marL="0">
+              <a:buNone/>
+            </a:pPr>
+            <a:r>
+              <a:rPr lang="en-US" sz="1400" b="1" dirty="0">
+                <a:solidFill>
+                  <a:srgbClr val="FFFFFF"/>
+                </a:solidFill>
+                <a:latin typeface="Calibri" pitchFamily="34" charset="0"/>
+                <a:ea typeface="Calibri" pitchFamily="34" charset="-122"/>
+                <a:cs typeface="Calibri" pitchFamily="34" charset="-120"/>
+              </a:rPr>
+              <a:t>L3</a:t>
+            </a:r>
+            <a:endParaRPr lang="en-US" sz="1400" dirty="0"/>
+          </a:p>
+        </p:txBody>
+      </p:sp>
+      <p:sp>
+        <p:nvSpPr>
+          <p:cNvPr id="15" name="Text 13"/>
+          <p:cNvSpPr/>
+          <p:nvPr/>
+        </p:nvSpPr>
+        <p:spPr>
+          <a:xfrm>
+            <a:off x="1143000" y="3054096"/>
+            <a:ext cx="4937760" cy="457200"/>
+          </a:xfrm>
+          <a:prstGeom prst="rect">
+            <a:avLst/>
+          </a:prstGeom>
+          <a:noFill/>
+          <a:ln/>
+        </p:spPr>
+        <p:txBody>
+          <a:bodyPr wrap="square" lIns="0" tIns="0" rIns="0" bIns="0" rtlCol="0" anchor="ctr"/>
+          <a:lstStyle/>
+          <a:p>
+            <a:pPr indent="0" marL="0">
+              <a:buNone/>
+            </a:pPr>
+            <a:r>
+              <a:rPr lang="en-US" sz="1300" b="1" dirty="0">
+                <a:solidFill>
+                  <a:srgbClr val="1E2761"/>
+                </a:solidFill>
+                <a:latin typeface="Calibri" pitchFamily="34" charset="0"/>
+                <a:ea typeface="Calibri" pitchFamily="34" charset="-122"/>
+                <a:cs typeface="Calibri" pitchFamily="34" charset="-120"/>
+              </a:rPr>
+              <a:t>Data-not-instructions wrap  </a:t>
+            </a:r>
+            <a:pPr indent="0" marL="0">
+              <a:buNone/>
+            </a:pPr>
+            <a:r>
+              <a:rPr lang="en-US" sz="1100" dirty="0">
+                <a:solidFill>
+                  <a:srgbClr val="555555"/>
+                </a:solidFill>
+                <a:latin typeface="Calibri" pitchFamily="34" charset="0"/>
+                <a:ea typeface="Calibri" pitchFamily="34" charset="-122"/>
+                <a:cs typeface="Calibri" pitchFamily="34" charset="-120"/>
+              </a:rPr>
+              <a:t>agents treat customer text as data, never as orders</a:t>
+            </a:r>
+            <a:endParaRPr lang="en-US" sz="1300" dirty="0"/>
+          </a:p>
+        </p:txBody>
+      </p:sp>
+      <p:sp>
+        <p:nvSpPr>
+          <p:cNvPr id="16" name="Text 14"/>
+          <p:cNvSpPr/>
+          <p:nvPr/>
+        </p:nvSpPr>
+        <p:spPr>
+          <a:xfrm>
+            <a:off x="6126480" y="3054096"/>
+            <a:ext cx="914400" cy="457200"/>
+          </a:xfrm>
+          <a:prstGeom prst="rect">
+            <a:avLst/>
+          </a:prstGeom>
+          <a:noFill/>
+          <a:ln/>
+        </p:spPr>
+        <p:txBody>
+          <a:bodyPr wrap="square" lIns="0" tIns="0" rIns="0" bIns="0" rtlCol="0" anchor="ctr"/>
+          <a:lstStyle/>
+          <a:p>
+            <a:pPr algn="ctr" indent="0" marL="0">
+              <a:buNone/>
+            </a:pPr>
+            <a:r>
+              <a:rPr lang="en-US" sz="1000" b="1" dirty="0">
+                <a:solidFill>
+                  <a:srgbClr val="2E7D32"/>
+                </a:solidFill>
+                <a:latin typeface="Calibri" pitchFamily="34" charset="0"/>
+                <a:ea typeface="Calibri" pitchFamily="34" charset="-122"/>
+                <a:cs typeface="Calibri" pitchFamily="34" charset="-120"/>
+              </a:rPr>
+              <a:t>LIVE</a:t>
+            </a:r>
+            <a:endParaRPr lang="en-US" sz="1000" dirty="0"/>
+          </a:p>
+        </p:txBody>
+      </p:sp>
+      <p:sp>
+        <p:nvSpPr>
+          <p:cNvPr id="17" name="Shape 15"/>
+          <p:cNvSpPr/>
+          <p:nvPr/>
+        </p:nvSpPr>
+        <p:spPr>
+          <a:xfrm>
+            <a:off x="457200" y="3621024"/>
+            <a:ext cx="548640" cy="457200"/>
+          </a:xfrm>
+          <a:prstGeom prst="roundRect">
+            <a:avLst>
+              <a:gd name="adj" fmla="val 12000"/>
+            </a:avLst>
+          </a:prstGeom>
+          <a:solidFill>
+            <a:srgbClr val="CADCFC"/>
+          </a:solidFill>
+          <a:ln w="12700">
+            <a:solidFill>
+              <a:srgbClr val="CADCFC"/>
+            </a:solidFill>
+            <a:prstDash val="solid"/>
+          </a:ln>
+        </p:spPr>
+      </p:sp>
+      <p:sp>
+        <p:nvSpPr>
+          <p:cNvPr id="18" name="Text 16"/>
+          <p:cNvSpPr/>
+          <p:nvPr/>
+        </p:nvSpPr>
+        <p:spPr>
+          <a:xfrm>
+            <a:off x="457200" y="3621024"/>
+            <a:ext cx="548640" cy="457200"/>
+          </a:xfrm>
+          <a:prstGeom prst="rect">
+            <a:avLst/>
+          </a:prstGeom>
+          <a:noFill/>
+          <a:ln/>
+        </p:spPr>
+        <p:txBody>
+          <a:bodyPr wrap="square" lIns="0" tIns="0" rIns="0" bIns="0" rtlCol="0" anchor="ctr"/>
+          <a:lstStyle/>
+          <a:p>
+            <a:pPr algn="ctr" indent="0" marL="0">
+              <a:buNone/>
+            </a:pPr>
+            <a:r>
+              <a:rPr lang="en-US" sz="1400" b="1" dirty="0">
+                <a:solidFill>
+                  <a:srgbClr val="1E2761"/>
+                </a:solidFill>
+                <a:latin typeface="Calibri" pitchFamily="34" charset="0"/>
+                <a:ea typeface="Calibri" pitchFamily="34" charset="-122"/>
+                <a:cs typeface="Calibri" pitchFamily="34" charset="-120"/>
+              </a:rPr>
+              <a:t>L4</a:t>
+            </a:r>
+            <a:endParaRPr lang="en-US" sz="1400" dirty="0"/>
+          </a:p>
+        </p:txBody>
+      </p:sp>
+      <p:sp>
+        <p:nvSpPr>
+          <p:cNvPr id="19" name="Text 17"/>
+          <p:cNvSpPr/>
+          <p:nvPr/>
+        </p:nvSpPr>
+        <p:spPr>
+          <a:xfrm>
+            <a:off x="1143000" y="3621024"/>
+            <a:ext cx="4937760" cy="457200"/>
+          </a:xfrm>
+          <a:prstGeom prst="rect">
+            <a:avLst/>
+          </a:prstGeom>
+          <a:noFill/>
+          <a:ln/>
+        </p:spPr>
+        <p:txBody>
+          <a:bodyPr wrap="square" lIns="0" tIns="0" rIns="0" bIns="0" rtlCol="0" anchor="ctr"/>
+          <a:lstStyle/>
+          <a:p>
+            <a:pPr indent="0" marL="0">
+              <a:buNone/>
+            </a:pPr>
+            <a:r>
+              <a:rPr lang="en-US" sz="1300" b="1" dirty="0">
+                <a:solidFill>
+                  <a:srgbClr val="1E2761"/>
+                </a:solidFill>
+                <a:latin typeface="Calibri" pitchFamily="34" charset="0"/>
+                <a:ea typeface="Calibri" pitchFamily="34" charset="-122"/>
+                <a:cs typeface="Calibri" pitchFamily="34" charset="-120"/>
+              </a:rPr>
+              <a:t>Output validation + canary  </a:t>
+            </a:r>
+            <a:pPr indent="0" marL="0">
+              <a:buNone/>
+            </a:pPr>
+            <a:r>
+              <a:rPr lang="en-US" sz="1100" dirty="0">
+                <a:solidFill>
+                  <a:srgbClr val="555555"/>
+                </a:solidFill>
+                <a:latin typeface="Calibri" pitchFamily="34" charset="0"/>
+                <a:ea typeface="Calibri" pitchFamily="34" charset="-122"/>
+                <a:cs typeface="Calibri" pitchFamily="34" charset="-120"/>
+              </a:rPr>
+              <a:t>catches leaks in the AI's own output</a:t>
+            </a:r>
+            <a:endParaRPr lang="en-US" sz="1300" dirty="0"/>
+          </a:p>
+        </p:txBody>
+      </p:sp>
+      <p:sp>
+        <p:nvSpPr>
+          <p:cNvPr id="20" name="Text 18"/>
+          <p:cNvSpPr/>
+          <p:nvPr/>
+        </p:nvSpPr>
+        <p:spPr>
+          <a:xfrm>
+            <a:off x="6126480" y="3621024"/>
+            <a:ext cx="914400" cy="457200"/>
+          </a:xfrm>
+          <a:prstGeom prst="rect">
+            <a:avLst/>
+          </a:prstGeom>
+          <a:noFill/>
+          <a:ln/>
+        </p:spPr>
+        <p:txBody>
+          <a:bodyPr wrap="square" lIns="0" tIns="0" rIns="0" bIns="0" rtlCol="0" anchor="ctr"/>
+          <a:lstStyle/>
+          <a:p>
+            <a:pPr algn="ctr" indent="0" marL="0">
+              <a:buNone/>
+            </a:pPr>
+            <a:r>
+              <a:rPr lang="en-US" sz="1000" b="1" dirty="0">
+                <a:solidFill>
+                  <a:srgbClr val="B26A00"/>
+                </a:solidFill>
+                <a:latin typeface="Calibri" pitchFamily="34" charset="0"/>
+                <a:ea typeface="Calibri" pitchFamily="34" charset="-122"/>
+                <a:cs typeface="Calibri" pitchFamily="34" charset="-120"/>
+              </a:rPr>
+              <a:t>DESIGNED</a:t>
+            </a:r>
+            <a:endParaRPr lang="en-US" sz="1000" dirty="0"/>
+          </a:p>
+        </p:txBody>
+      </p:sp>
+      <p:sp>
+        <p:nvSpPr>
+          <p:cNvPr id="21" name="Shape 19"/>
+          <p:cNvSpPr/>
+          <p:nvPr/>
+        </p:nvSpPr>
+        <p:spPr>
+          <a:xfrm>
+            <a:off x="457200" y="4187952"/>
+            <a:ext cx="548640" cy="457200"/>
+          </a:xfrm>
+          <a:prstGeom prst="roundRect">
+            <a:avLst>
+              <a:gd name="adj" fmla="val 12000"/>
+            </a:avLst>
+          </a:prstGeom>
+          <a:solidFill>
+            <a:srgbClr val="CADCFC"/>
+          </a:solidFill>
+          <a:ln w="12700">
+            <a:solidFill>
+              <a:srgbClr val="CADCFC"/>
+            </a:solidFill>
+            <a:prstDash val="solid"/>
+          </a:ln>
+        </p:spPr>
+      </p:sp>
+      <p:sp>
+        <p:nvSpPr>
+          <p:cNvPr id="22" name="Text 20"/>
+          <p:cNvSpPr/>
+          <p:nvPr/>
+        </p:nvSpPr>
+        <p:spPr>
+          <a:xfrm>
+            <a:off x="457200" y="4187952"/>
+            <a:ext cx="548640" cy="457200"/>
+          </a:xfrm>
+          <a:prstGeom prst="rect">
+            <a:avLst/>
+          </a:prstGeom>
+          <a:noFill/>
+          <a:ln/>
+        </p:spPr>
+        <p:txBody>
+          <a:bodyPr wrap="square" lIns="0" tIns="0" rIns="0" bIns="0" rtlCol="0" anchor="ctr"/>
+          <a:lstStyle/>
+          <a:p>
+            <a:pPr algn="ctr" indent="0" marL="0">
+              <a:buNone/>
+            </a:pPr>
+            <a:r>
+              <a:rPr lang="en-US" sz="1400" b="1" dirty="0">
+                <a:solidFill>
+                  <a:srgbClr val="1E2761"/>
+                </a:solidFill>
+                <a:latin typeface="Calibri" pitchFamily="34" charset="0"/>
+                <a:ea typeface="Calibri" pitchFamily="34" charset="-122"/>
+                <a:cs typeface="Calibri" pitchFamily="34" charset="-120"/>
+              </a:rPr>
+              <a:t>L5</a:t>
+            </a:r>
+            <a:endParaRPr lang="en-US" sz="1400" dirty="0"/>
+          </a:p>
+        </p:txBody>
+      </p:sp>
+      <p:sp>
+        <p:nvSpPr>
+          <p:cNvPr id="23" name="Text 21"/>
+          <p:cNvSpPr/>
+          <p:nvPr/>
+        </p:nvSpPr>
+        <p:spPr>
+          <a:xfrm>
+            <a:off x="1143000" y="4187952"/>
+            <a:ext cx="4937760" cy="457200"/>
+          </a:xfrm>
+          <a:prstGeom prst="rect">
+            <a:avLst/>
+          </a:prstGeom>
+          <a:noFill/>
+          <a:ln/>
+        </p:spPr>
+        <p:txBody>
+          <a:bodyPr wrap="square" lIns="0" tIns="0" rIns="0" bIns="0" rtlCol="0" anchor="ctr"/>
+          <a:lstStyle/>
+          <a:p>
+            <a:pPr indent="0" marL="0">
+              <a:buNone/>
+            </a:pPr>
+            <a:r>
+              <a:rPr lang="en-US" sz="1300" b="1" dirty="0">
+                <a:solidFill>
+                  <a:srgbClr val="1E2761"/>
+                </a:solidFill>
+                <a:latin typeface="Calibri" pitchFamily="34" charset="0"/>
+                <a:ea typeface="Calibri" pitchFamily="34" charset="-122"/>
+                <a:cs typeface="Calibri" pitchFamily="34" charset="-120"/>
+              </a:rPr>
+              <a:t>Memory sanitization  </a:t>
+            </a:r>
+            <a:pPr indent="0" marL="0">
+              <a:buNone/>
+            </a:pPr>
+            <a:r>
+              <a:rPr lang="en-US" sz="1100" dirty="0">
+                <a:solidFill>
+                  <a:srgbClr val="555555"/>
+                </a:solidFill>
+                <a:latin typeface="Calibri" pitchFamily="34" charset="0"/>
+                <a:ea typeface="Calibri" pitchFamily="34" charset="-122"/>
+                <a:cs typeface="Calibri" pitchFamily="34" charset="-120"/>
+              </a:rPr>
+              <a:t>cleans what agents recall from memory</a:t>
+            </a:r>
+            <a:endParaRPr lang="en-US" sz="1300" dirty="0"/>
+          </a:p>
+        </p:txBody>
+      </p:sp>
+      <p:sp>
+        <p:nvSpPr>
+          <p:cNvPr id="24" name="Text 22"/>
+          <p:cNvSpPr/>
+          <p:nvPr/>
+        </p:nvSpPr>
+        <p:spPr>
+          <a:xfrm>
+            <a:off x="6126480" y="4187952"/>
+            <a:ext cx="914400" cy="457200"/>
+          </a:xfrm>
+          <a:prstGeom prst="rect">
+            <a:avLst/>
+          </a:prstGeom>
+          <a:noFill/>
+          <a:ln/>
+        </p:spPr>
+        <p:txBody>
+          <a:bodyPr wrap="square" lIns="0" tIns="0" rIns="0" bIns="0" rtlCol="0" anchor="ctr"/>
+          <a:lstStyle/>
+          <a:p>
+            <a:pPr algn="ctr" indent="0" marL="0">
+              <a:buNone/>
+            </a:pPr>
+            <a:r>
+              <a:rPr lang="en-US" sz="1000" b="1" dirty="0">
+                <a:solidFill>
+                  <a:srgbClr val="B26A00"/>
+                </a:solidFill>
+                <a:latin typeface="Calibri" pitchFamily="34" charset="0"/>
+                <a:ea typeface="Calibri" pitchFamily="34" charset="-122"/>
+                <a:cs typeface="Calibri" pitchFamily="34" charset="-120"/>
+              </a:rPr>
+              <a:t>DESIGNED</a:t>
+            </a:r>
+            <a:endParaRPr lang="en-US" sz="1000" dirty="0"/>
+          </a:p>
+        </p:txBody>
+      </p:sp>
+      <p:sp>
+        <p:nvSpPr>
+          <p:cNvPr id="25" name="Shape 23"/>
+          <p:cNvSpPr/>
+          <p:nvPr/>
+        </p:nvSpPr>
+        <p:spPr>
+          <a:xfrm>
+            <a:off x="457200" y="4754880"/>
+            <a:ext cx="548640" cy="457200"/>
+          </a:xfrm>
+          <a:prstGeom prst="roundRect">
+            <a:avLst>
+              <a:gd name="adj" fmla="val 12000"/>
+            </a:avLst>
+          </a:prstGeom>
+          <a:solidFill>
+            <a:srgbClr val="CADCFC"/>
+          </a:solidFill>
+          <a:ln w="12700">
+            <a:solidFill>
+              <a:srgbClr val="CADCFC"/>
+            </a:solidFill>
+            <a:prstDash val="solid"/>
+          </a:ln>
+        </p:spPr>
+      </p:sp>
+      <p:sp>
+        <p:nvSpPr>
+          <p:cNvPr id="26" name="Text 24"/>
+          <p:cNvSpPr/>
+          <p:nvPr/>
+        </p:nvSpPr>
+        <p:spPr>
+          <a:xfrm>
+            <a:off x="457200" y="4754880"/>
+            <a:ext cx="548640" cy="457200"/>
+          </a:xfrm>
+          <a:prstGeom prst="rect">
+            <a:avLst/>
+          </a:prstGeom>
+          <a:noFill/>
+          <a:ln/>
+        </p:spPr>
+        <p:txBody>
+          <a:bodyPr wrap="square" lIns="0" tIns="0" rIns="0" bIns="0" rtlCol="0" anchor="ctr"/>
+          <a:lstStyle/>
+          <a:p>
+            <a:pPr algn="ctr" indent="0" marL="0">
+              <a:buNone/>
+            </a:pPr>
+            <a:r>
+              <a:rPr lang="en-US" sz="1400" b="1" dirty="0">
+                <a:solidFill>
+                  <a:srgbClr val="1E2761"/>
+                </a:solidFill>
+                <a:latin typeface="Calibri" pitchFamily="34" charset="0"/>
+                <a:ea typeface="Calibri" pitchFamily="34" charset="-122"/>
+                <a:cs typeface="Calibri" pitchFamily="34" charset="-120"/>
+              </a:rPr>
+              <a:t>L6</a:t>
+            </a:r>
+            <a:endParaRPr lang="en-US" sz="1400" dirty="0"/>
+          </a:p>
+        </p:txBody>
+      </p:sp>
+      <p:sp>
+        <p:nvSpPr>
+          <p:cNvPr id="27" name="Text 25"/>
+          <p:cNvSpPr/>
+          <p:nvPr/>
+        </p:nvSpPr>
+        <p:spPr>
+          <a:xfrm>
+            <a:off x="1143000" y="4754880"/>
+            <a:ext cx="4937760" cy="457200"/>
+          </a:xfrm>
+          <a:prstGeom prst="rect">
+            <a:avLst/>
+          </a:prstGeom>
+          <a:noFill/>
+          <a:ln/>
+        </p:spPr>
+        <p:txBody>
+          <a:bodyPr wrap="square" lIns="0" tIns="0" rIns="0" bIns="0" rtlCol="0" anchor="ctr"/>
+          <a:lstStyle/>
+          <a:p>
+            <a:pPr indent="0" marL="0">
+              <a:buNone/>
+            </a:pPr>
+            <a:r>
+              <a:rPr lang="en-US" sz="1300" b="1" dirty="0">
+                <a:solidFill>
+                  <a:srgbClr val="1E2761"/>
+                </a:solidFill>
+                <a:latin typeface="Calibri" pitchFamily="34" charset="0"/>
+                <a:ea typeface="Calibri" pitchFamily="34" charset="-122"/>
+                <a:cs typeface="Calibri" pitchFamily="34" charset="-120"/>
+              </a:rPr>
+              <a:t>Agent-to-agent trust  </a:t>
+            </a:r>
+            <a:pPr indent="0" marL="0">
+              <a:buNone/>
+            </a:pPr>
+            <a:r>
+              <a:rPr lang="en-US" sz="1100" dirty="0">
+                <a:solidFill>
+                  <a:srgbClr val="555555"/>
+                </a:solidFill>
+                <a:latin typeface="Calibri" pitchFamily="34" charset="0"/>
+                <a:ea typeface="Calibri" pitchFamily="34" charset="-122"/>
+                <a:cs typeface="Calibri" pitchFamily="34" charset="-120"/>
+              </a:rPr>
+              <a:t>one hijacked agent can't infect the next</a:t>
+            </a:r>
+            <a:endParaRPr lang="en-US" sz="1300" dirty="0"/>
+          </a:p>
+        </p:txBody>
+      </p:sp>
+      <p:sp>
+        <p:nvSpPr>
+          <p:cNvPr id="28" name="Text 26"/>
+          <p:cNvSpPr/>
+          <p:nvPr/>
+        </p:nvSpPr>
+        <p:spPr>
+          <a:xfrm>
+            <a:off x="6126480" y="4754880"/>
+            <a:ext cx="914400" cy="457200"/>
+          </a:xfrm>
+          <a:prstGeom prst="rect">
+            <a:avLst/>
+          </a:prstGeom>
+          <a:noFill/>
+          <a:ln/>
+        </p:spPr>
+        <p:txBody>
+          <a:bodyPr wrap="square" lIns="0" tIns="0" rIns="0" bIns="0" rtlCol="0" anchor="ctr"/>
+          <a:lstStyle/>
+          <a:p>
+            <a:pPr algn="ctr" indent="0" marL="0">
+              <a:buNone/>
+            </a:pPr>
+            <a:r>
+              <a:rPr lang="en-US" sz="1000" b="1" dirty="0">
+                <a:solidFill>
+                  <a:srgbClr val="B26A00"/>
+                </a:solidFill>
+                <a:latin typeface="Calibri" pitchFamily="34" charset="0"/>
+                <a:ea typeface="Calibri" pitchFamily="34" charset="-122"/>
+                <a:cs typeface="Calibri" pitchFamily="34" charset="-120"/>
+              </a:rPr>
+              <a:t>DESIGNED</a:t>
+            </a:r>
+            <a:endParaRPr lang="en-US" sz="1000" dirty="0"/>
+          </a:p>
+        </p:txBody>
+      </p:sp>
+      <p:sp>
+        <p:nvSpPr>
+          <p:cNvPr id="29" name="Shape 27"/>
+          <p:cNvSpPr/>
+          <p:nvPr/>
+        </p:nvSpPr>
+        <p:spPr>
+          <a:xfrm>
+            <a:off x="457200" y="5321808"/>
+            <a:ext cx="548640" cy="457200"/>
+          </a:xfrm>
+          <a:prstGeom prst="roundRect">
+            <a:avLst>
+              <a:gd name="adj" fmla="val 12000"/>
+            </a:avLst>
+          </a:prstGeom>
+          <a:solidFill>
+            <a:srgbClr val="1E2761"/>
+          </a:solidFill>
+          <a:ln w="12700">
+            <a:solidFill>
+              <a:srgbClr val="1E2761"/>
+            </a:solidFill>
+            <a:prstDash val="solid"/>
+          </a:ln>
+        </p:spPr>
+      </p:sp>
+      <p:sp>
+        <p:nvSpPr>
+          <p:cNvPr id="30" name="Text 28"/>
+          <p:cNvSpPr/>
+          <p:nvPr/>
+        </p:nvSpPr>
+        <p:spPr>
+          <a:xfrm>
+            <a:off x="457200" y="5321808"/>
+            <a:ext cx="548640" cy="457200"/>
+          </a:xfrm>
+          <a:prstGeom prst="rect">
+            <a:avLst/>
+          </a:prstGeom>
+          <a:noFill/>
+          <a:ln/>
+        </p:spPr>
+        <p:txBody>
+          <a:bodyPr wrap="square" lIns="0" tIns="0" rIns="0" bIns="0" rtlCol="0" anchor="ctr"/>
+          <a:lstStyle/>
+          <a:p>
+            <a:pPr algn="ctr" indent="0" marL="0">
+              <a:buNone/>
+            </a:pPr>
+            <a:r>
+              <a:rPr lang="en-US" sz="1400" b="1" dirty="0">
+                <a:solidFill>
+                  <a:srgbClr val="FFFFFF"/>
+                </a:solidFill>
+                <a:latin typeface="Calibri" pitchFamily="34" charset="0"/>
+                <a:ea typeface="Calibri" pitchFamily="34" charset="-122"/>
+                <a:cs typeface="Calibri" pitchFamily="34" charset="-120"/>
+              </a:rPr>
+              <a:t>L7</a:t>
+            </a:r>
+            <a:endParaRPr lang="en-US" sz="1400" dirty="0"/>
+          </a:p>
+        </p:txBody>
+      </p:sp>
+      <p:sp>
+        <p:nvSpPr>
+          <p:cNvPr id="31" name="Text 29"/>
+          <p:cNvSpPr/>
+          <p:nvPr/>
+        </p:nvSpPr>
+        <p:spPr>
+          <a:xfrm>
+            <a:off x="1143000" y="5321808"/>
+            <a:ext cx="4937760" cy="457200"/>
+          </a:xfrm>
+          <a:prstGeom prst="rect">
+            <a:avLst/>
+          </a:prstGeom>
+          <a:noFill/>
+          <a:ln/>
+        </p:spPr>
+        <p:txBody>
+          <a:bodyPr wrap="square" lIns="0" tIns="0" rIns="0" bIns="0" rtlCol="0" anchor="ctr"/>
+          <a:lstStyle/>
+          <a:p>
+            <a:pPr indent="0" marL="0">
+              <a:buNone/>
+            </a:pPr>
+            <a:r>
+              <a:rPr lang="en-US" sz="1300" b="1" dirty="0">
+                <a:solidFill>
+                  <a:srgbClr val="1E2761"/>
+                </a:solidFill>
+                <a:latin typeface="Calibri" pitchFamily="34" charset="0"/>
+                <a:ea typeface="Calibri" pitchFamily="34" charset="-122"/>
+                <a:cs typeface="Calibri" pitchFamily="34" charset="-120"/>
+              </a:rPr>
+              <a:t>Audit log + dashboard  </a:t>
+            </a:r>
+            <a:pPr indent="0" marL="0">
+              <a:buNone/>
+            </a:pPr>
+            <a:r>
+              <a:rPr lang="en-US" sz="1100" dirty="0">
+                <a:solidFill>
+                  <a:srgbClr val="555555"/>
+                </a:solidFill>
+                <a:latin typeface="Calibri" pitchFamily="34" charset="0"/>
+                <a:ea typeface="Calibri" pitchFamily="34" charset="-122"/>
+                <a:cs typeface="Calibri" pitchFamily="34" charset="-120"/>
+              </a:rPr>
+              <a:t>every block recorded per tenant — SOC2-ready</a:t>
+            </a:r>
+            <a:endParaRPr lang="en-US" sz="1300" dirty="0"/>
+          </a:p>
+        </p:txBody>
+      </p:sp>
+      <p:sp>
+        <p:nvSpPr>
+          <p:cNvPr id="32" name="Text 30"/>
+          <p:cNvSpPr/>
+          <p:nvPr/>
+        </p:nvSpPr>
+        <p:spPr>
+          <a:xfrm>
+            <a:off x="6126480" y="5321808"/>
+            <a:ext cx="914400" cy="457200"/>
+          </a:xfrm>
+          <a:prstGeom prst="rect">
+            <a:avLst/>
+          </a:prstGeom>
+          <a:noFill/>
+          <a:ln/>
+        </p:spPr>
+        <p:txBody>
+          <a:bodyPr wrap="square" lIns="0" tIns="0" rIns="0" bIns="0" rtlCol="0" anchor="ctr"/>
+          <a:lstStyle/>
+          <a:p>
+            <a:pPr algn="ctr" indent="0" marL="0">
+              <a:buNone/>
+            </a:pPr>
+            <a:r>
+              <a:rPr lang="en-US" sz="1000" b="1" dirty="0">
+                <a:solidFill>
+                  <a:srgbClr val="2E7D32"/>
+                </a:solidFill>
+                <a:latin typeface="Calibri" pitchFamily="34" charset="0"/>
+                <a:ea typeface="Calibri" pitchFamily="34" charset="-122"/>
+                <a:cs typeface="Calibri" pitchFamily="34" charset="-120"/>
+              </a:rPr>
+              <a:t>LIVE</a:t>
+            </a:r>
+            <a:endParaRPr lang="en-US" sz="1000" dirty="0"/>
+          </a:p>
+        </p:txBody>
+      </p:sp>
+      <p:sp>
+        <p:nvSpPr>
+          <p:cNvPr id="33" name="Text 31"/>
+          <p:cNvSpPr/>
+          <p:nvPr/>
+        </p:nvSpPr>
+        <p:spPr>
+          <a:xfrm>
+            <a:off x="7315200" y="1554480"/>
+            <a:ext cx="4389120" cy="274320"/>
+          </a:xfrm>
+          <a:prstGeom prst="rect">
+            <a:avLst/>
+          </a:prstGeom>
+          <a:noFill/>
+          <a:ln/>
+        </p:spPr>
+        <p:txBody>
+          <a:bodyPr wrap="square" rtlCol="0" anchor="ctr"/>
+          <a:lstStyle/>
+          <a:p>
+            <a:pPr indent="0" marL="0">
+              <a:buNone/>
+            </a:pPr>
+            <a:r>
+              <a:rPr lang="en-US" sz="1200" b="1" spc="200" kern="0" dirty="0">
+                <a:solidFill>
+                  <a:srgbClr val="F96167"/>
+                </a:solidFill>
+                <a:latin typeface="Calibri" pitchFamily="34" charset="0"/>
+                <a:ea typeface="Calibri" pitchFamily="34" charset="-122"/>
+                <a:cs typeface="Calibri" pitchFamily="34" charset="-120"/>
+              </a:rPr>
+              <a:t>THE PROOF</a:t>
+            </a:r>
+            <a:endParaRPr lang="en-US" sz="1200" dirty="0"/>
+          </a:p>
+        </p:txBody>
+      </p:sp>
+      <p:sp>
+        <p:nvSpPr>
+          <p:cNvPr id="34" name="Shape 32"/>
+          <p:cNvSpPr/>
+          <p:nvPr/>
+        </p:nvSpPr>
+        <p:spPr>
+          <a:xfrm>
+            <a:off x="7315200" y="1920240"/>
+            <a:ext cx="4389120" cy="1051560"/>
+          </a:xfrm>
+          <a:prstGeom prst="roundRect">
+            <a:avLst>
+              <a:gd name="adj" fmla="val 8696"/>
+            </a:avLst>
+          </a:prstGeom>
+          <a:solidFill>
+            <a:srgbClr val="CADCFC"/>
+          </a:solidFill>
+          <a:ln w="12700">
+            <a:solidFill>
+              <a:srgbClr val="CADCFC"/>
+            </a:solidFill>
+            <a:prstDash val="solid"/>
+          </a:ln>
+        </p:spPr>
+      </p:sp>
+      <p:sp>
+        <p:nvSpPr>
+          <p:cNvPr id="35" name="Text 33"/>
+          <p:cNvSpPr/>
+          <p:nvPr/>
+        </p:nvSpPr>
+        <p:spPr>
+          <a:xfrm>
+            <a:off x="7315200" y="1965960"/>
+            <a:ext cx="4389120" cy="594360"/>
+          </a:xfrm>
+          <a:prstGeom prst="rect">
+            <a:avLst/>
+          </a:prstGeom>
+          <a:noFill/>
+          <a:ln/>
+        </p:spPr>
+        <p:txBody>
+          <a:bodyPr wrap="square" lIns="0" tIns="0" rIns="0" bIns="0" rtlCol="0" anchor="ctr"/>
+          <a:lstStyle/>
+          <a:p>
+            <a:pPr algn="ctr" indent="0" marL="0">
+              <a:buNone/>
+            </a:pPr>
+            <a:r>
+              <a:rPr lang="en-US" sz="3400" b="1" dirty="0">
+                <a:solidFill>
+                  <a:srgbClr val="1E2761"/>
+                </a:solidFill>
+                <a:latin typeface="Georgia" pitchFamily="34" charset="0"/>
+                <a:ea typeface="Georgia" pitchFamily="34" charset="-122"/>
+                <a:cs typeface="Georgia" pitchFamily="34" charset="-120"/>
+              </a:rPr>
+              <a:t>25 / 25</a:t>
+            </a:r>
+            <a:endParaRPr lang="en-US" sz="3400" dirty="0"/>
+          </a:p>
+        </p:txBody>
+      </p:sp>
+      <p:sp>
+        <p:nvSpPr>
+          <p:cNvPr id="36" name="Text 34"/>
+          <p:cNvSpPr/>
+          <p:nvPr/>
+        </p:nvSpPr>
+        <p:spPr>
+          <a:xfrm>
+            <a:off x="7315200" y="2560320"/>
+            <a:ext cx="4389120" cy="365760"/>
+          </a:xfrm>
+          <a:prstGeom prst="rect">
+            <a:avLst/>
+          </a:prstGeom>
+          <a:noFill/>
+          <a:ln/>
+        </p:spPr>
+        <p:txBody>
+          <a:bodyPr wrap="square" lIns="0" tIns="0" rIns="0" bIns="0" rtlCol="0" anchor="ctr"/>
+          <a:lstStyle/>
+          <a:p>
+            <a:pPr algn="ctr" indent="0" marL="0">
+              <a:buNone/>
+            </a:pPr>
+            <a:r>
+              <a:rPr lang="en-US" sz="1200" i="1" dirty="0">
+                <a:solidFill>
+                  <a:srgbClr val="1E2761"/>
+                </a:solidFill>
+                <a:latin typeface="Calibri" pitchFamily="34" charset="0"/>
+                <a:ea typeface="Calibri" pitchFamily="34" charset="-122"/>
+                <a:cs typeface="Calibri" pitchFamily="34" charset="-120"/>
+              </a:rPr>
+              <a:t>fresh attacks blocked in security testing</a:t>
+            </a:r>
+            <a:endParaRPr lang="en-US" sz="1200" dirty="0"/>
+          </a:p>
+        </p:txBody>
+      </p:sp>
+      <p:sp>
+        <p:nvSpPr>
+          <p:cNvPr id="37" name="Text 35"/>
+          <p:cNvSpPr/>
+          <p:nvPr/>
+        </p:nvSpPr>
+        <p:spPr>
+          <a:xfrm>
+            <a:off x="7360920" y="3154680"/>
+            <a:ext cx="4343400" cy="1371600"/>
+          </a:xfrm>
+          <a:prstGeom prst="rect">
+            <a:avLst/>
+          </a:prstGeom>
+          <a:noFill/>
+          <a:ln/>
+        </p:spPr>
+        <p:txBody>
+          <a:bodyPr wrap="square" lIns="0" tIns="0" rIns="0" bIns="0" rtlCol="0" anchor="ctr"/>
+          <a:lstStyle/>
+          <a:p>
+            <a:pPr indent="0" marL="0">
+              <a:lnSpc>
+                <a:spcPct val="135000"/>
+              </a:lnSpc>
+              <a:buNone/>
+            </a:pPr>
+            <a:r>
+              <a:rPr lang="en-US" sz="1300" b="1" dirty="0">
+                <a:solidFill>
+                  <a:srgbClr val="1E2761"/>
+                </a:solidFill>
+                <a:latin typeface="Calibri" pitchFamily="34" charset="0"/>
+                <a:ea typeface="Calibri" pitchFamily="34" charset="-122"/>
+                <a:cs typeface="Calibri" pitchFamily="34" charset="-120"/>
+              </a:rPr>
+              <a:t>✓ 4 of 7 layers live</a:t>
+            </a:r>
+            <a:pPr indent="0" marL="0">
+              <a:lnSpc>
+                <a:spcPct val="135000"/>
+              </a:lnSpc>
+              <a:buNone/>
+            </a:pPr>
+            <a:r>
+              <a:rPr lang="en-US" sz="1300" dirty="0">
+                <a:solidFill>
+                  <a:srgbClr val="555555"/>
+                </a:solidFill>
+                <a:latin typeface="Calibri" pitchFamily="34" charset="0"/>
+                <a:ea typeface="Calibri" pitchFamily="34" charset="-122"/>
+                <a:cs typeface="Calibri" pitchFamily="34" charset="-120"/>
+              </a:rPr>
+              <a:t>  (3 more designed)
+</a:t>
+            </a:r>
+            <a:pPr indent="0" marL="0">
+              <a:lnSpc>
+                <a:spcPct val="135000"/>
+              </a:lnSpc>
+              <a:buNone/>
+            </a:pPr>
+            <a:r>
+              <a:rPr lang="en-US" sz="1300" dirty="0">
+                <a:solidFill>
+                  <a:srgbClr val="1A1A1A"/>
+                </a:solidFill>
+                <a:latin typeface="Calibri" pitchFamily="34" charset="0"/>
+                <a:ea typeface="Calibri" pitchFamily="34" charset="-122"/>
+                <a:cs typeface="Calibri" pitchFamily="34" charset="-120"/>
+              </a:rPr>
+              <a:t>✓ Raj code review: 96 / 100
+</a:t>
+            </a:r>
+            <a:pPr indent="0" marL="0">
+              <a:lnSpc>
+                <a:spcPct val="135000"/>
+              </a:lnSpc>
+              <a:buNone/>
+            </a:pPr>
+            <a:r>
+              <a:rPr lang="en-US" sz="1300" dirty="0">
+                <a:solidFill>
+                  <a:srgbClr val="1A1A1A"/>
+                </a:solidFill>
+                <a:latin typeface="Calibri" pitchFamily="34" charset="0"/>
+                <a:ea typeface="Calibri" pitchFamily="34" charset="-122"/>
+                <a:cs typeface="Calibri" pitchFamily="34" charset="-120"/>
+              </a:rPr>
+              <a:t>✓ Frozen 100-case attack benchmark
+</a:t>
+            </a:r>
+            <a:pPr indent="0" marL="0">
+              <a:lnSpc>
+                <a:spcPct val="135000"/>
+              </a:lnSpc>
+              <a:buNone/>
+            </a:pPr>
+            <a:r>
+              <a:rPr lang="en-US" sz="1300" dirty="0">
+                <a:solidFill>
+                  <a:srgbClr val="1A1A1A"/>
+                </a:solidFill>
+                <a:latin typeface="Calibri" pitchFamily="34" charset="0"/>
+                <a:ea typeface="Calibri" pitchFamily="34" charset="-122"/>
+                <a:cs typeface="Calibri" pitchFamily="34" charset="-120"/>
+              </a:rPr>
+              <a:t>✓ Every block logged per tenant</a:t>
+            </a:r>
+            <a:endParaRPr lang="en-US" sz="1300" dirty="0"/>
+          </a:p>
+        </p:txBody>
+      </p:sp>
+      <p:sp>
+        <p:nvSpPr>
+          <p:cNvPr id="38" name="Shape 36"/>
+          <p:cNvSpPr/>
+          <p:nvPr/>
+        </p:nvSpPr>
+        <p:spPr>
+          <a:xfrm>
+            <a:off x="7315200" y="4663440"/>
+            <a:ext cx="4389120" cy="1325880"/>
+          </a:xfrm>
+          <a:prstGeom prst="roundRect">
+            <a:avLst>
+              <a:gd name="adj" fmla="val 6897"/>
+            </a:avLst>
+          </a:prstGeom>
+          <a:solidFill>
+            <a:srgbClr val="1E2761"/>
+          </a:solidFill>
+          <a:ln w="12700">
+            <a:solidFill>
+              <a:srgbClr val="1E2761"/>
+            </a:solidFill>
+            <a:prstDash val="solid"/>
+          </a:ln>
+        </p:spPr>
+      </p:sp>
+      <p:sp>
+        <p:nvSpPr>
+          <p:cNvPr id="39" name="Text 37"/>
+          <p:cNvSpPr/>
+          <p:nvPr/>
+        </p:nvSpPr>
+        <p:spPr>
+          <a:xfrm>
+            <a:off x="7498080" y="4754880"/>
+            <a:ext cx="4023360" cy="274320"/>
+          </a:xfrm>
+          <a:prstGeom prst="rect">
+            <a:avLst/>
+          </a:prstGeom>
+          <a:noFill/>
+          <a:ln/>
+        </p:spPr>
+        <p:txBody>
+          <a:bodyPr wrap="square" rtlCol="0" anchor="ctr"/>
+          <a:lstStyle/>
+          <a:p>
+            <a:pPr indent="0" marL="0">
+              <a:buNone/>
+            </a:pPr>
+            <a:r>
+              <a:rPr lang="en-US" sz="1100" b="1" spc="200" kern="0" dirty="0">
+                <a:solidFill>
+                  <a:srgbClr val="CADCFC"/>
+                </a:solidFill>
+                <a:latin typeface="Calibri" pitchFamily="34" charset="0"/>
+                <a:ea typeface="Calibri" pitchFamily="34" charset="-122"/>
+                <a:cs typeface="Calibri" pitchFamily="34" charset="-120"/>
+              </a:rPr>
+              <a:t>WHY IT MATTERS</a:t>
+            </a:r>
+            <a:endParaRPr lang="en-US" sz="1100" dirty="0"/>
+          </a:p>
+        </p:txBody>
+      </p:sp>
+      <p:sp>
+        <p:nvSpPr>
+          <p:cNvPr id="40" name="Text 38"/>
+          <p:cNvSpPr/>
+          <p:nvPr/>
+        </p:nvSpPr>
+        <p:spPr>
+          <a:xfrm>
+            <a:off x="7498080" y="5074920"/>
+            <a:ext cx="4023360" cy="822960"/>
+          </a:xfrm>
+          <a:prstGeom prst="rect">
+            <a:avLst/>
+          </a:prstGeom>
+          <a:noFill/>
+          <a:ln/>
+        </p:spPr>
+        <p:txBody>
+          <a:bodyPr wrap="square" lIns="0" tIns="0" rIns="0" bIns="0" rtlCol="0" anchor="ctr"/>
+          <a:lstStyle/>
+          <a:p>
+            <a:pPr indent="0" marL="0">
+              <a:buNone/>
+            </a:pPr>
+            <a:r>
+              <a:rPr lang="en-US" sz="1200" dirty="0">
+                <a:solidFill>
+                  <a:srgbClr val="FFFFFF"/>
+                </a:solidFill>
+                <a:latin typeface="Calibri" pitchFamily="34" charset="0"/>
+                <a:ea typeface="Calibri" pitchFamily="34" charset="-122"/>
+                <a:cs typeface="Calibri" pitchFamily="34" charset="-120"/>
+              </a:rPr>
+              <a:t>A malicious request is rejected before it ever reaches a paid model — so an attacker can't leak data, hijack an agent, or run up your bill.</a:t>
+            </a:r>
+            <a:endParaRPr lang="en-US" sz="1200" dirty="0"/>
+          </a:p>
+        </p:txBody>
+      </p:sp>
+      <p:sp>
+        <p:nvSpPr>
+          <p:cNvPr id="41" name="Text 39"/>
+          <p:cNvSpPr/>
+          <p:nvPr/>
+        </p:nvSpPr>
+        <p:spPr>
+          <a:xfrm>
+            <a:off x="457200" y="6263640"/>
+            <a:ext cx="11247120" cy="365760"/>
+          </a:xfrm>
+          <a:prstGeom prst="rect">
+            <a:avLst/>
+          </a:prstGeom>
+          <a:noFill/>
+          <a:ln/>
+        </p:spPr>
+        <p:txBody>
+          <a:bodyPr wrap="square" lIns="0" tIns="0" rIns="0" bIns="0" rtlCol="0" anchor="ctr"/>
+          <a:lstStyle/>
+          <a:p>
+            <a:pPr algn="ctr" indent="0" marL="0">
+              <a:buNone/>
+            </a:pPr>
+            <a:r>
+              <a:rPr lang="en-US" sz="1200" i="1" dirty="0">
+                <a:solidFill>
+                  <a:srgbClr val="555555"/>
+                </a:solidFill>
+                <a:latin typeface="Calibri" pitchFamily="34" charset="0"/>
+                <a:ea typeface="Calibri" pitchFamily="34" charset="-122"/>
+                <a:cs typeface="Calibri" pitchFamily="34" charset="-120"/>
+              </a:rPr>
+              <a:t>3 gates before a token is spent · 2 more before agents trust each other · </a:t>
+            </a:r>
+            <a:pPr algn="ctr" indent="0" marL="0">
+              <a:buNone/>
+            </a:pPr>
+            <a:r>
+              <a:rPr lang="en-US" sz="1200" b="1" i="1" dirty="0">
+                <a:solidFill>
+                  <a:srgbClr val="1E2761"/>
+                </a:solidFill>
+                <a:latin typeface="Calibri" pitchFamily="34" charset="0"/>
+                <a:ea typeface="Calibri" pitchFamily="34" charset="-122"/>
+                <a:cs typeface="Calibri" pitchFamily="34" charset="-120"/>
+              </a:rPr>
+              <a:t>every attempt logged.</a:t>
+            </a:r>
+            <a:endParaRPr lang="en-US" sz="1200" dirty="0"/>
+          </a:p>
+        </p:txBody>
+      </p:sp>
+    </p:spTree>
+  </p:cSld>
+  <p:clrMapOvr>
+    <a:masterClrMapping/>
+  </p:clrMapOvr>
+</p:sld>
+</file>
+
 <file path=ppt/theme/theme1.xml><?xml version="1.0" encoding="utf-8"?>
 <a:theme xmlns:a="http://schemas.openxmlformats.org/drawingml/2006/main" name="Office Theme">
   <a:themeElements>

</xml_diff>